<commit_message>
Replace slide 10 with weighted commission + Bolt+ value analysis
Co-authored-by: Cursor <cursoragent@cursor.com>
</commit_message>
<xml_diff>
--- a/Master-Zoo-Bolt-Food-Partnership.pptx
+++ b/Master-Zoo-Bolt-Food-Partnership.pptx
@@ -3397,7 +3397,7 @@
                 </a:solidFill>
                 <a:latin typeface="Arial"/>
               </a:rPr>
-              <a:t>ПОТЕНЦІАЛ СПІВПРАЦІ · BOLT+</a:t>
+              <a:t>ОРІЄНТОВНІ УМОВИ · BOLT+</a:t>
             </a:r>
           </a:p>
           <a:p>
@@ -3408,7 +3408,7 @@
                 </a:solidFill>
                 <a:latin typeface="Arial"/>
               </a:rPr>
-              <a:t>Bolt+: 0,4% комісії проти +20% GMV</a:t>
+              <a:t>Середньозважена комісія та цінність Bolt+</a:t>
             </a:r>
           </a:p>
         </p:txBody>
@@ -3509,8 +3509,8 @@
         </p:nvSpPr>
         <p:spPr>
           <a:xfrm>
-            <a:off x="777240" y="1993392"/>
-            <a:ext cx="3520440" cy="1645920"/>
+            <a:off x="777240" y="1975104"/>
+            <a:ext cx="3520440" cy="1691640"/>
           </a:xfrm>
           <a:prstGeom prst="rect">
             <a:avLst/>
@@ -3524,24 +3524,24 @@
           <a:lstStyle/>
           <a:p>
             <a:r>
-              <a:rPr sz="1350" b="1">
+              <a:rPr sz="1300" b="1">
                 <a:solidFill>
                   <a:srgbClr val="2F313F"/>
                 </a:solidFill>
                 <a:latin typeface="Arial"/>
               </a:rPr>
-              <a:t>Вартість Bolt+</a:t>
-            </a:r>
-          </a:p>
-          <a:p>
-            <a:r>
-              <a:rPr sz="1000" b="0">
+              <a:t>Сценарій 1 — рекомендований</a:t>
+            </a:r>
+          </a:p>
+          <a:p>
+            <a:r>
+              <a:rPr sz="950" b="0">
                 <a:solidFill>
                   <a:srgbClr val="6B7080"/>
                 </a:solidFill>
                 <a:latin typeface="Arial"/>
               </a:rPr>
-              <a:t>середньозважена надбавка (20% × 2%)</a:t>
+              <a:t>база 10% · передаєте ціни зі знижками</a:t>
             </a:r>
           </a:p>
           <a:p>
@@ -3552,29 +3552,29 @@
                 </a:solidFill>
                 <a:latin typeface="Arial"/>
               </a:rPr>
-              <a:t>+0,4 п.п.</a:t>
-            </a:r>
-          </a:p>
-          <a:p>
-            <a:r>
-              <a:rPr sz="1150" b="0">
+              <a:t>10,3%</a:t>
+            </a:r>
+          </a:p>
+          <a:p>
+            <a:r>
+              <a:rPr sz="1050" b="0">
                 <a:solidFill>
                   <a:srgbClr val="6B7080"/>
                 </a:solidFill>
                 <a:latin typeface="Arial"/>
               </a:rPr>
-              <a:t>≈ 10 200 ₴ / міс (міс 6)</a:t>
-            </a:r>
-          </a:p>
-          <a:p>
-            <a:r>
-              <a:rPr sz="1150" b="0">
+              <a:t>середньозважена</a:t>
+            </a:r>
+          </a:p>
+          <a:p>
+            <a:r>
+              <a:rPr sz="1100" b="0">
                 <a:solidFill>
                   <a:srgbClr val="6B7080"/>
                 </a:solidFill>
                 <a:latin typeface="Arial"/>
               </a:rPr>
-              <a:t>≈ 46 000 ₴ за 6 міс</a:t>
+              <a:t>комісія ≈ 1,18 млн ₴ / 6 міс</a:t>
             </a:r>
           </a:p>
         </p:txBody>
@@ -3631,8 +3631,8 @@
         </p:nvSpPr>
         <p:spPr>
           <a:xfrm>
-            <a:off x="4892040" y="1993392"/>
-            <a:ext cx="3520440" cy="1645920"/>
+            <a:off x="4892040" y="1975104"/>
+            <a:ext cx="3520440" cy="1691640"/>
           </a:xfrm>
           <a:prstGeom prst="rect">
             <a:avLst/>
@@ -3646,24 +3646,24 @@
           <a:lstStyle/>
           <a:p>
             <a:r>
-              <a:rPr sz="1350" b="1">
+              <a:rPr sz="1300" b="1">
                 <a:solidFill>
                   <a:srgbClr val="FFFFFF"/>
                 </a:solidFill>
                 <a:latin typeface="Arial"/>
               </a:rPr>
-              <a:t>Приріст GMV від Bolt+</a:t>
-            </a:r>
-          </a:p>
-          <a:p>
-            <a:r>
-              <a:rPr sz="1000" b="0">
+              <a:t>Сценарій 2 — без передачі знижок</a:t>
+            </a:r>
+          </a:p>
+          <a:p>
+            <a:r>
+              <a:rPr sz="950" b="0">
                 <a:solidFill>
                   <a:srgbClr val="EAFFF4"/>
                 </a:solidFill>
                 <a:latin typeface="Arial"/>
               </a:rPr>
-              <a:t>частіші замовлення преміум-аудиторії</a:t>
+              <a:t>база 12% · ціни без урахування знижок</a:t>
             </a:r>
           </a:p>
           <a:p>
@@ -3674,29 +3674,29 @@
                 </a:solidFill>
                 <a:latin typeface="Arial"/>
               </a:rPr>
-              <a:t>+20%</a:t>
-            </a:r>
-          </a:p>
-          <a:p>
-            <a:r>
-              <a:rPr sz="1150" b="0">
+              <a:t>12,3%</a:t>
+            </a:r>
+          </a:p>
+          <a:p>
+            <a:r>
+              <a:rPr sz="1050" b="0">
+                <a:solidFill>
+                  <a:srgbClr val="EAFFF4"/>
+                </a:solidFill>
+                <a:latin typeface="Arial"/>
+              </a:rPr>
+              <a:t>середньозважена</a:t>
+            </a:r>
+          </a:p>
+          <a:p>
+            <a:r>
+              <a:rPr sz="1100" b="0">
                 <a:solidFill>
                   <a:srgbClr val="FFFFFF"/>
                 </a:solidFill>
                 <a:latin typeface="Arial"/>
               </a:rPr>
-              <a:t>+510 000 ₴ / міс (міс 6)</a:t>
-            </a:r>
-          </a:p>
-          <a:p>
-            <a:r>
-              <a:rPr sz="1150" b="0">
-                <a:solidFill>
-                  <a:srgbClr val="FFFFFF"/>
-                </a:solidFill>
-                <a:latin typeface="Arial"/>
-              </a:rPr>
-              <a:t>+2,3 млн ₴ за 6 міс</a:t>
+              <a:t>комісія ≈ 1,41 млн ₴ / 6 міс</a:t>
             </a:r>
           </a:p>
         </p:txBody>
@@ -3753,8 +3753,8 @@
         </p:nvSpPr>
         <p:spPr>
           <a:xfrm>
-            <a:off x="731520" y="3968496"/>
-            <a:ext cx="7680960" cy="420624"/>
+            <a:off x="731520" y="3941063"/>
+            <a:ext cx="7680960" cy="457200"/>
           </a:xfrm>
           <a:prstGeom prst="rect">
             <a:avLst/>
@@ -3769,13 +3769,13 @@
           <a:p>
             <a:pPr algn="ctr"/>
             <a:r>
-              <a:rPr sz="1250" b="1">
+              <a:rPr sz="1200" b="1">
                 <a:solidFill>
                   <a:srgbClr val="FFFFFF"/>
                 </a:solidFill>
                 <a:latin typeface="Arial"/>
               </a:rPr>
-              <a:t>Кожна 1 ₴ комісії → ~40–50 ₴ GMV · 0,4% «з'їдає» лише ~2% приросту</a:t>
+              <a:t>Без Bolt+ оборот −10% (−1,15 млн ₴) → чистими −~1 млн ₴ · кожна 1 ₴ комісії → ~7 ₴ обороту</a:t>
             </a:r>
           </a:p>
         </p:txBody>
@@ -3809,7 +3809,7 @@
                 </a:solidFill>
                 <a:latin typeface="Arial"/>
               </a:rPr>
-              <a:t>Розрахунок: AOV 850 ₴, до 3 000 замовлень/міс, ~11,5 млн ₴ GMV за 6 міс. Bolt+ ≈ 20% продажів, +2% на ці замовлення.</a:t>
+              <a:t>GMV 11,5 млн ₴ (з Bolt+) · частка Bolt+ 15% × +2% = +0,3 п.п. · +2% лише на замовлення підписників.</a:t>
             </a:r>
           </a:p>
         </p:txBody>

</xml_diff>